<commit_message>
Day 35 (Morning) : Practice Function with condition, loop and multiple function.
Day 35 (Morning) : Practice Function with condition, loop and multiple function.
</commit_message>
<xml_diff>
--- a/09_Improvement/Improvement Areas.pptx
+++ b/09_Improvement/Improvement Areas.pptx
@@ -3153,13 +3153,13 @@
   <p:clrMapOvr>
     <a:masterClrMapping/>
   </p:clrMapOvr>
-  <mc:AlternateContent xmlns:mc="http://schemas.openxmlformats.org/markup-compatibility/2006">
-    <mc:Choice xmlns:p15="http://schemas.microsoft.com/office/powerpoint/2012/main" Requires="p15">
+  <mc:AlternateContent xmlns:mc="http://schemas.openxmlformats.org/markup-compatibility/2006" xmlns:p15="http://schemas.microsoft.com/office/powerpoint/2012/main">
+    <mc:Choice Requires="p15">
       <p:transition xmlns:p14="http://schemas.microsoft.com/office/powerpoint/2010/main" spd="slow" p14:dur="1250">
         <p15:prstTrans prst="peelOff"/>
       </p:transition>
     </mc:Choice>
-    <mc:Fallback>
+    <mc:Fallback xmlns="">
       <p:transition spd="slow">
         <p:fade/>
       </p:transition>
@@ -3196,13 +3196,13 @@
   <p:sldLayoutIdLst>
     <p:sldLayoutId id="2147483649" r:id="rId1"/>
   </p:sldLayoutIdLst>
-  <mc:AlternateContent xmlns:mc="http://schemas.openxmlformats.org/markup-compatibility/2006">
-    <mc:Choice xmlns:p15="http://schemas.microsoft.com/office/powerpoint/2012/main" Requires="p15">
+  <mc:AlternateContent xmlns:mc="http://schemas.openxmlformats.org/markup-compatibility/2006" xmlns:p15="http://schemas.microsoft.com/office/powerpoint/2012/main">
+    <mc:Choice Requires="p15">
       <p:transition xmlns:p14="http://schemas.microsoft.com/office/powerpoint/2010/main" spd="slow" p14:dur="1250">
         <p15:prstTrans prst="peelOff"/>
       </p:transition>
     </mc:Choice>
-    <mc:Fallback>
+    <mc:Fallback xmlns="">
       <p:transition spd="slow">
         <p:fade/>
       </p:transition>
@@ -4749,13 +4749,13 @@
   <p:clrMapOvr>
     <a:masterClrMapping/>
   </p:clrMapOvr>
-  <mc:AlternateContent xmlns:mc="http://schemas.openxmlformats.org/markup-compatibility/2006">
-    <mc:Choice xmlns:p15="http://schemas.microsoft.com/office/powerpoint/2012/main" Requires="p15">
+  <mc:AlternateContent xmlns:mc="http://schemas.openxmlformats.org/markup-compatibility/2006" xmlns:p15="http://schemas.microsoft.com/office/powerpoint/2012/main">
+    <mc:Choice Requires="p15">
       <p:transition xmlns:p14="http://schemas.microsoft.com/office/powerpoint/2010/main" spd="slow" p14:dur="1250">
         <p15:prstTrans prst="peelOff"/>
       </p:transition>
     </mc:Choice>
-    <mc:Fallback>
+    <mc:Fallback xmlns="">
       <p:transition spd="slow">
         <p:fade/>
       </p:transition>
@@ -5548,13 +5548,13 @@
   <p:clrMapOvr>
     <a:masterClrMapping/>
   </p:clrMapOvr>
-  <mc:AlternateContent xmlns:mc="http://schemas.openxmlformats.org/markup-compatibility/2006">
-    <mc:Choice xmlns:p15="http://schemas.microsoft.com/office/powerpoint/2012/main" Requires="p15">
+  <mc:AlternateContent xmlns:mc="http://schemas.openxmlformats.org/markup-compatibility/2006" xmlns:p15="http://schemas.microsoft.com/office/powerpoint/2012/main">
+    <mc:Choice Requires="p15">
       <p:transition xmlns:p14="http://schemas.microsoft.com/office/powerpoint/2010/main" spd="slow" p14:dur="1250">
         <p15:prstTrans prst="peelOff"/>
       </p:transition>
     </mc:Choice>
-    <mc:Fallback>
+    <mc:Fallback xmlns="">
       <p:transition spd="slow">
         <p:fade/>
       </p:transition>
@@ -6539,13 +6539,13 @@
   <p:clrMapOvr>
     <a:masterClrMapping/>
   </p:clrMapOvr>
-  <mc:AlternateContent xmlns:mc="http://schemas.openxmlformats.org/markup-compatibility/2006">
-    <mc:Choice xmlns:p15="http://schemas.microsoft.com/office/powerpoint/2012/main" Requires="p15">
+  <mc:AlternateContent xmlns:mc="http://schemas.openxmlformats.org/markup-compatibility/2006" xmlns:p15="http://schemas.microsoft.com/office/powerpoint/2012/main">
+    <mc:Choice Requires="p15">
       <p:transition xmlns:p14="http://schemas.microsoft.com/office/powerpoint/2010/main" spd="slow" p14:dur="1250">
         <p15:prstTrans prst="peelOff"/>
       </p:transition>
     </mc:Choice>
-    <mc:Fallback>
+    <mc:Fallback xmlns="">
       <p:transition spd="slow">
         <p:fade/>
       </p:transition>
@@ -7111,13 +7111,13 @@
   <p:clrMapOvr>
     <a:masterClrMapping/>
   </p:clrMapOvr>
-  <mc:AlternateContent xmlns:mc="http://schemas.openxmlformats.org/markup-compatibility/2006">
-    <mc:Choice xmlns:p15="http://schemas.microsoft.com/office/powerpoint/2012/main" Requires="p15">
+  <mc:AlternateContent xmlns:mc="http://schemas.openxmlformats.org/markup-compatibility/2006" xmlns:p15="http://schemas.microsoft.com/office/powerpoint/2012/main">
+    <mc:Choice Requires="p15">
       <p:transition xmlns:p14="http://schemas.microsoft.com/office/powerpoint/2010/main" spd="slow" p14:dur="1250">
         <p15:prstTrans prst="peelOff"/>
       </p:transition>
     </mc:Choice>
-    <mc:Fallback>
+    <mc:Fallback xmlns="">
       <p:transition spd="slow">
         <p:fade/>
       </p:transition>
@@ -8321,13 +8321,13 @@
   <p:clrMapOvr>
     <a:masterClrMapping/>
   </p:clrMapOvr>
-  <mc:AlternateContent xmlns:mc="http://schemas.openxmlformats.org/markup-compatibility/2006">
-    <mc:Choice xmlns:p15="http://schemas.microsoft.com/office/powerpoint/2012/main" Requires="p15">
+  <mc:AlternateContent xmlns:mc="http://schemas.openxmlformats.org/markup-compatibility/2006" xmlns:p15="http://schemas.microsoft.com/office/powerpoint/2012/main">
+    <mc:Choice Requires="p15">
       <p:transition xmlns:p14="http://schemas.microsoft.com/office/powerpoint/2010/main" spd="slow" p14:dur="1250">
         <p15:prstTrans prst="peelOff"/>
       </p:transition>
     </mc:Choice>
-    <mc:Fallback>
+    <mc:Fallback xmlns="">
       <p:transition spd="slow">
         <p:fade/>
       </p:transition>
@@ -8788,13 +8788,13 @@
   <p:clrMapOvr>
     <a:masterClrMapping/>
   </p:clrMapOvr>
-  <mc:AlternateContent xmlns:mc="http://schemas.openxmlformats.org/markup-compatibility/2006">
-    <mc:Choice xmlns:p15="http://schemas.microsoft.com/office/powerpoint/2012/main" Requires="p15">
+  <mc:AlternateContent xmlns:mc="http://schemas.openxmlformats.org/markup-compatibility/2006" xmlns:p15="http://schemas.microsoft.com/office/powerpoint/2012/main">
+    <mc:Choice Requires="p15">
       <p:transition xmlns:p14="http://schemas.microsoft.com/office/powerpoint/2010/main" spd="slow" p14:dur="1250">
         <p15:prstTrans prst="peelOff"/>
       </p:transition>
     </mc:Choice>
-    <mc:Fallback>
+    <mc:Fallback xmlns="">
       <p:transition spd="slow">
         <p:fade/>
       </p:transition>
@@ -9434,13 +9434,13 @@
   <p:clrMapOvr>
     <a:masterClrMapping/>
   </p:clrMapOvr>
-  <mc:AlternateContent xmlns:mc="http://schemas.openxmlformats.org/markup-compatibility/2006">
-    <mc:Choice xmlns:p15="http://schemas.microsoft.com/office/powerpoint/2012/main" Requires="p15">
+  <mc:AlternateContent xmlns:mc="http://schemas.openxmlformats.org/markup-compatibility/2006" xmlns:p15="http://schemas.microsoft.com/office/powerpoint/2012/main">
+    <mc:Choice Requires="p15">
       <p:transition xmlns:p14="http://schemas.microsoft.com/office/powerpoint/2010/main" spd="slow" p14:dur="1250">
         <p15:prstTrans prst="peelOff"/>
       </p:transition>
     </mc:Choice>
-    <mc:Fallback>
+    <mc:Fallback xmlns="">
       <p:transition spd="slow">
         <p:fade/>
       </p:transition>
@@ -10007,13 +10007,13 @@
   <p:clrMapOvr>
     <a:masterClrMapping/>
   </p:clrMapOvr>
-  <mc:AlternateContent xmlns:mc="http://schemas.openxmlformats.org/markup-compatibility/2006">
-    <mc:Choice xmlns:p15="http://schemas.microsoft.com/office/powerpoint/2012/main" Requires="p15">
+  <mc:AlternateContent xmlns:mc="http://schemas.openxmlformats.org/markup-compatibility/2006" xmlns:p15="http://schemas.microsoft.com/office/powerpoint/2012/main">
+    <mc:Choice Requires="p15">
       <p:transition xmlns:p14="http://schemas.microsoft.com/office/powerpoint/2010/main" spd="slow" p14:dur="1250">
         <p15:prstTrans prst="peelOff"/>
       </p:transition>
     </mc:Choice>
-    <mc:Fallback>
+    <mc:Fallback xmlns="">
       <p:transition spd="slow">
         <p:fade/>
       </p:transition>
@@ -10288,13 +10288,13 @@
   <p:clrMapOvr>
     <a:masterClrMapping/>
   </p:clrMapOvr>
-  <mc:AlternateContent xmlns:mc="http://schemas.openxmlformats.org/markup-compatibility/2006">
-    <mc:Choice xmlns:p15="http://schemas.microsoft.com/office/powerpoint/2012/main" Requires="p15">
+  <mc:AlternateContent xmlns:mc="http://schemas.openxmlformats.org/markup-compatibility/2006" xmlns:p15="http://schemas.microsoft.com/office/powerpoint/2012/main">
+    <mc:Choice Requires="p15">
       <p:transition xmlns:p14="http://schemas.microsoft.com/office/powerpoint/2010/main" spd="slow" p14:dur="1250">
         <p15:prstTrans prst="peelOff"/>
       </p:transition>
     </mc:Choice>
-    <mc:Fallback>
+    <mc:Fallback xmlns="">
       <p:transition spd="slow">
         <p:fade/>
       </p:transition>
@@ -10848,13 +10848,13 @@
   <p:clrMapOvr>
     <a:masterClrMapping/>
   </p:clrMapOvr>
-  <mc:AlternateContent xmlns:mc="http://schemas.openxmlformats.org/markup-compatibility/2006">
-    <mc:Choice xmlns:p15="http://schemas.microsoft.com/office/powerpoint/2012/main" Requires="p15">
+  <mc:AlternateContent xmlns:mc="http://schemas.openxmlformats.org/markup-compatibility/2006" xmlns:p15="http://schemas.microsoft.com/office/powerpoint/2012/main">
+    <mc:Choice Requires="p15">
       <p:transition xmlns:p14="http://schemas.microsoft.com/office/powerpoint/2010/main" spd="slow" p14:dur="1250">
         <p15:prstTrans prst="peelOff"/>
       </p:transition>
     </mc:Choice>
-    <mc:Fallback>
+    <mc:Fallback xmlns="">
       <p:transition spd="slow">
         <p:fade/>
       </p:transition>
@@ -11514,13 +11514,13 @@
   <p:clrMapOvr>
     <a:masterClrMapping/>
   </p:clrMapOvr>
-  <mc:AlternateContent xmlns:mc="http://schemas.openxmlformats.org/markup-compatibility/2006">
-    <mc:Choice xmlns:p15="http://schemas.microsoft.com/office/powerpoint/2012/main" Requires="p15">
+  <mc:AlternateContent xmlns:mc="http://schemas.openxmlformats.org/markup-compatibility/2006" xmlns:p15="http://schemas.microsoft.com/office/powerpoint/2012/main">
+    <mc:Choice Requires="p15">
       <p:transition xmlns:p14="http://schemas.microsoft.com/office/powerpoint/2010/main" spd="slow" p14:dur="1250">
         <p15:prstTrans prst="peelOff"/>
       </p:transition>
     </mc:Choice>
-    <mc:Fallback>
+    <mc:Fallback xmlns="">
       <p:transition spd="slow">
         <p:fade/>
       </p:transition>
@@ -12267,13 +12267,13 @@
   <p:clrMapOvr>
     <a:masterClrMapping/>
   </p:clrMapOvr>
-  <mc:AlternateContent xmlns:mc="http://schemas.openxmlformats.org/markup-compatibility/2006">
-    <mc:Choice xmlns:p15="http://schemas.microsoft.com/office/powerpoint/2012/main" Requires="p15">
+  <mc:AlternateContent xmlns:mc="http://schemas.openxmlformats.org/markup-compatibility/2006" xmlns:p15="http://schemas.microsoft.com/office/powerpoint/2012/main">
+    <mc:Choice Requires="p15">
       <p:transition xmlns:p14="http://schemas.microsoft.com/office/powerpoint/2010/main" spd="slow" p14:dur="1250">
         <p15:prstTrans prst="peelOff"/>
       </p:transition>
     </mc:Choice>
-    <mc:Fallback>
+    <mc:Fallback xmlns="">
       <p:transition spd="slow">
         <p:fade/>
       </p:transition>
@@ -12859,13 +12859,13 @@
   <p:clrMapOvr>
     <a:masterClrMapping/>
   </p:clrMapOvr>
-  <mc:AlternateContent xmlns:mc="http://schemas.openxmlformats.org/markup-compatibility/2006">
-    <mc:Choice xmlns:p15="http://schemas.microsoft.com/office/powerpoint/2012/main" Requires="p15">
+  <mc:AlternateContent xmlns:mc="http://schemas.openxmlformats.org/markup-compatibility/2006" xmlns:p15="http://schemas.microsoft.com/office/powerpoint/2012/main">
+    <mc:Choice Requires="p15">
       <p:transition xmlns:p14="http://schemas.microsoft.com/office/powerpoint/2010/main" spd="slow" p14:dur="1250">
         <p15:prstTrans prst="peelOff"/>
       </p:transition>
     </mc:Choice>
-    <mc:Fallback>
+    <mc:Fallback xmlns="">
       <p:transition spd="slow">
         <p:fade/>
       </p:transition>
@@ -13365,13 +13365,13 @@
   <p:clrMapOvr>
     <a:masterClrMapping/>
   </p:clrMapOvr>
-  <mc:AlternateContent xmlns:mc="http://schemas.openxmlformats.org/markup-compatibility/2006">
-    <mc:Choice xmlns:p15="http://schemas.microsoft.com/office/powerpoint/2012/main" Requires="p15">
+  <mc:AlternateContent xmlns:mc="http://schemas.openxmlformats.org/markup-compatibility/2006" xmlns:p15="http://schemas.microsoft.com/office/powerpoint/2012/main">
+    <mc:Choice Requires="p15">
       <p:transition xmlns:p14="http://schemas.microsoft.com/office/powerpoint/2010/main" spd="slow" p14:dur="1250">
         <p15:prstTrans prst="peelOff"/>
       </p:transition>
     </mc:Choice>
-    <mc:Fallback>
+    <mc:Fallback xmlns="">
       <p:transition spd="slow">
         <p:fade/>
       </p:transition>
@@ -14091,13 +14091,13 @@
   <p:clrMapOvr>
     <a:masterClrMapping/>
   </p:clrMapOvr>
-  <mc:AlternateContent xmlns:mc="http://schemas.openxmlformats.org/markup-compatibility/2006">
-    <mc:Choice xmlns:p15="http://schemas.microsoft.com/office/powerpoint/2012/main" Requires="p15">
+  <mc:AlternateContent xmlns:mc="http://schemas.openxmlformats.org/markup-compatibility/2006" xmlns:p15="http://schemas.microsoft.com/office/powerpoint/2012/main">
+    <mc:Choice Requires="p15">
       <p:transition xmlns:p14="http://schemas.microsoft.com/office/powerpoint/2010/main" spd="slow" p14:dur="1250">
         <p15:prstTrans prst="peelOff"/>
       </p:transition>
     </mc:Choice>
-    <mc:Fallback>
+    <mc:Fallback xmlns="">
       <p:transition spd="slow">
         <p:fade/>
       </p:transition>
@@ -15166,13 +15166,13 @@
   <p:clrMapOvr>
     <a:masterClrMapping/>
   </p:clrMapOvr>
-  <mc:AlternateContent xmlns:mc="http://schemas.openxmlformats.org/markup-compatibility/2006">
-    <mc:Choice xmlns:p15="http://schemas.microsoft.com/office/powerpoint/2012/main" Requires="p15">
+  <mc:AlternateContent xmlns:mc="http://schemas.openxmlformats.org/markup-compatibility/2006" xmlns:p15="http://schemas.microsoft.com/office/powerpoint/2012/main">
+    <mc:Choice Requires="p15">
       <p:transition xmlns:p14="http://schemas.microsoft.com/office/powerpoint/2010/main" spd="slow" p14:dur="1250">
         <p15:prstTrans prst="peelOff"/>
       </p:transition>
     </mc:Choice>
-    <mc:Fallback>
+    <mc:Fallback xmlns="">
       <p:transition spd="slow">
         <p:fade/>
       </p:transition>
@@ -16602,13 +16602,13 @@
   <p:clrMapOvr>
     <a:masterClrMapping/>
   </p:clrMapOvr>
-  <mc:AlternateContent xmlns:mc="http://schemas.openxmlformats.org/markup-compatibility/2006">
-    <mc:Choice xmlns:p15="http://schemas.microsoft.com/office/powerpoint/2012/main" Requires="p15">
+  <mc:AlternateContent xmlns:mc="http://schemas.openxmlformats.org/markup-compatibility/2006" xmlns:p15="http://schemas.microsoft.com/office/powerpoint/2012/main">
+    <mc:Choice Requires="p15">
       <p:transition xmlns:p14="http://schemas.microsoft.com/office/powerpoint/2010/main" spd="slow" p14:dur="1250">
         <p15:prstTrans prst="peelOff"/>
       </p:transition>
     </mc:Choice>
-    <mc:Fallback>
+    <mc:Fallback xmlns="">
       <p:transition spd="slow">
         <p:fade/>
       </p:transition>
@@ -17325,13 +17325,13 @@
   <p:clrMapOvr>
     <a:masterClrMapping/>
   </p:clrMapOvr>
-  <mc:AlternateContent xmlns:mc="http://schemas.openxmlformats.org/markup-compatibility/2006">
-    <mc:Choice xmlns:p15="http://schemas.microsoft.com/office/powerpoint/2012/main" Requires="p15">
+  <mc:AlternateContent xmlns:mc="http://schemas.openxmlformats.org/markup-compatibility/2006" xmlns:p15="http://schemas.microsoft.com/office/powerpoint/2012/main">
+    <mc:Choice Requires="p15">
       <p:transition xmlns:p14="http://schemas.microsoft.com/office/powerpoint/2010/main" spd="slow" p14:dur="1250">
         <p15:prstTrans prst="peelOff"/>
       </p:transition>
     </mc:Choice>
-    <mc:Fallback>
+    <mc:Fallback xmlns="">
       <p:transition spd="slow">
         <p:fade/>
       </p:transition>
@@ -18000,13 +18000,13 @@
   <p:clrMapOvr>
     <a:masterClrMapping/>
   </p:clrMapOvr>
-  <mc:AlternateContent xmlns:mc="http://schemas.openxmlformats.org/markup-compatibility/2006">
-    <mc:Choice xmlns:p15="http://schemas.microsoft.com/office/powerpoint/2012/main" Requires="p15">
+  <mc:AlternateContent xmlns:mc="http://schemas.openxmlformats.org/markup-compatibility/2006" xmlns:p15="http://schemas.microsoft.com/office/powerpoint/2012/main">
+    <mc:Choice Requires="p15">
       <p:transition xmlns:p14="http://schemas.microsoft.com/office/powerpoint/2010/main" spd="slow" p14:dur="1250">
         <p15:prstTrans prst="peelOff"/>
       </p:transition>
     </mc:Choice>
-    <mc:Fallback>
+    <mc:Fallback xmlns="">
       <p:transition spd="slow">
         <p:fade/>
       </p:transition>
@@ -18772,13 +18772,13 @@
   <p:clrMapOvr>
     <a:masterClrMapping/>
   </p:clrMapOvr>
-  <mc:AlternateContent xmlns:mc="http://schemas.openxmlformats.org/markup-compatibility/2006">
-    <mc:Choice xmlns:p15="http://schemas.microsoft.com/office/powerpoint/2012/main" Requires="p15">
+  <mc:AlternateContent xmlns:mc="http://schemas.openxmlformats.org/markup-compatibility/2006" xmlns:p15="http://schemas.microsoft.com/office/powerpoint/2012/main">
+    <mc:Choice Requires="p15">
       <p:transition xmlns:p14="http://schemas.microsoft.com/office/powerpoint/2010/main" spd="slow" p14:dur="1250">
         <p15:prstTrans prst="peelOff"/>
       </p:transition>
     </mc:Choice>
-    <mc:Fallback>
+    <mc:Fallback xmlns="">
       <p:transition spd="slow">
         <p:fade/>
       </p:transition>
@@ -19611,13 +19611,13 @@
   <p:clrMapOvr>
     <a:masterClrMapping/>
   </p:clrMapOvr>
-  <mc:AlternateContent xmlns:mc="http://schemas.openxmlformats.org/markup-compatibility/2006">
-    <mc:Choice xmlns:p15="http://schemas.microsoft.com/office/powerpoint/2012/main" Requires="p15">
+  <mc:AlternateContent xmlns:mc="http://schemas.openxmlformats.org/markup-compatibility/2006" xmlns:p15="http://schemas.microsoft.com/office/powerpoint/2012/main">
+    <mc:Choice Requires="p15">
       <p:transition xmlns:p14="http://schemas.microsoft.com/office/powerpoint/2010/main" spd="slow" p14:dur="1250">
         <p15:prstTrans prst="peelOff"/>
       </p:transition>
     </mc:Choice>
-    <mc:Fallback>
+    <mc:Fallback xmlns="">
       <p:transition spd="slow">
         <p:fade/>
       </p:transition>
@@ -20344,13 +20344,13 @@
   <p:clrMapOvr>
     <a:masterClrMapping/>
   </p:clrMapOvr>
-  <mc:AlternateContent xmlns:mc="http://schemas.openxmlformats.org/markup-compatibility/2006">
-    <mc:Choice xmlns:p15="http://schemas.microsoft.com/office/powerpoint/2012/main" Requires="p15">
+  <mc:AlternateContent xmlns:mc="http://schemas.openxmlformats.org/markup-compatibility/2006" xmlns:p15="http://schemas.microsoft.com/office/powerpoint/2012/main">
+    <mc:Choice Requires="p15">
       <p:transition xmlns:p14="http://schemas.microsoft.com/office/powerpoint/2010/main" spd="slow" p14:dur="1250">
         <p15:prstTrans prst="peelOff"/>
       </p:transition>
     </mc:Choice>
-    <mc:Fallback>
+    <mc:Fallback xmlns="">
       <p:transition spd="slow">
         <p:fade/>
       </p:transition>
@@ -21269,13 +21269,13 @@
   <p:clrMapOvr>
     <a:masterClrMapping/>
   </p:clrMapOvr>
-  <mc:AlternateContent xmlns:mc="http://schemas.openxmlformats.org/markup-compatibility/2006">
-    <mc:Choice xmlns:p15="http://schemas.microsoft.com/office/powerpoint/2012/main" Requires="p15">
+  <mc:AlternateContent xmlns:mc="http://schemas.openxmlformats.org/markup-compatibility/2006" xmlns:p15="http://schemas.microsoft.com/office/powerpoint/2012/main">
+    <mc:Choice Requires="p15">
       <p:transition xmlns:p14="http://schemas.microsoft.com/office/powerpoint/2010/main" spd="slow" p14:dur="1250">
         <p15:prstTrans prst="peelOff"/>
       </p:transition>
     </mc:Choice>
-    <mc:Fallback>
+    <mc:Fallback xmlns="">
       <p:transition spd="slow">
         <p:fade/>
       </p:transition>
@@ -22479,13 +22479,13 @@
   <p:clrMapOvr>
     <a:masterClrMapping/>
   </p:clrMapOvr>
-  <mc:AlternateContent xmlns:mc="http://schemas.openxmlformats.org/markup-compatibility/2006">
-    <mc:Choice xmlns:p15="http://schemas.microsoft.com/office/powerpoint/2012/main" Requires="p15">
+  <mc:AlternateContent xmlns:mc="http://schemas.openxmlformats.org/markup-compatibility/2006" xmlns:p15="http://schemas.microsoft.com/office/powerpoint/2012/main">
+    <mc:Choice Requires="p15">
       <p:transition xmlns:p14="http://schemas.microsoft.com/office/powerpoint/2010/main" spd="slow" p14:dur="1250">
         <p15:prstTrans prst="peelOff"/>
       </p:transition>
     </mc:Choice>
-    <mc:Fallback>
+    <mc:Fallback xmlns="">
       <p:transition spd="slow">
         <p:fade/>
       </p:transition>
@@ -24414,13 +24414,13 @@
   <p:clrMapOvr>
     <a:masterClrMapping/>
   </p:clrMapOvr>
-  <mc:AlternateContent xmlns:mc="http://schemas.openxmlformats.org/markup-compatibility/2006">
-    <mc:Choice xmlns:p15="http://schemas.microsoft.com/office/powerpoint/2012/main" Requires="p15">
+  <mc:AlternateContent xmlns:mc="http://schemas.openxmlformats.org/markup-compatibility/2006" xmlns:p15="http://schemas.microsoft.com/office/powerpoint/2012/main">
+    <mc:Choice Requires="p15">
       <p:transition xmlns:p14="http://schemas.microsoft.com/office/powerpoint/2010/main" spd="slow" p14:dur="1250">
         <p15:prstTrans prst="peelOff"/>
       </p:transition>
     </mc:Choice>
-    <mc:Fallback>
+    <mc:Fallback xmlns="">
       <p:transition spd="slow">
         <p:fade/>
       </p:transition>
@@ -25039,13 +25039,13 @@
   <p:clrMapOvr>
     <a:masterClrMapping/>
   </p:clrMapOvr>
-  <mc:AlternateContent xmlns:mc="http://schemas.openxmlformats.org/markup-compatibility/2006">
-    <mc:Choice xmlns:p15="http://schemas.microsoft.com/office/powerpoint/2012/main" Requires="p15">
+  <mc:AlternateContent xmlns:mc="http://schemas.openxmlformats.org/markup-compatibility/2006" xmlns:p15="http://schemas.microsoft.com/office/powerpoint/2012/main">
+    <mc:Choice Requires="p15">
       <p:transition xmlns:p14="http://schemas.microsoft.com/office/powerpoint/2010/main" spd="slow" p14:dur="1250">
         <p15:prstTrans prst="peelOff"/>
       </p:transition>
     </mc:Choice>
-    <mc:Fallback>
+    <mc:Fallback xmlns="">
       <p:transition spd="slow">
         <p:fade/>
       </p:transition>
@@ -26024,13 +26024,13 @@
   <p:clrMapOvr>
     <a:masterClrMapping/>
   </p:clrMapOvr>
-  <mc:AlternateContent xmlns:mc="http://schemas.openxmlformats.org/markup-compatibility/2006">
-    <mc:Choice xmlns:p15="http://schemas.microsoft.com/office/powerpoint/2012/main" Requires="p15">
+  <mc:AlternateContent xmlns:mc="http://schemas.openxmlformats.org/markup-compatibility/2006" xmlns:p15="http://schemas.microsoft.com/office/powerpoint/2012/main">
+    <mc:Choice Requires="p15">
       <p:transition xmlns:p14="http://schemas.microsoft.com/office/powerpoint/2010/main" spd="slow" p14:dur="1250">
         <p15:prstTrans prst="peelOff"/>
       </p:transition>
     </mc:Choice>
-    <mc:Fallback>
+    <mc:Fallback xmlns="">
       <p:transition spd="slow">
         <p:fade/>
       </p:transition>
@@ -27474,13 +27474,13 @@
   <p:clrMapOvr>
     <a:masterClrMapping/>
   </p:clrMapOvr>
-  <mc:AlternateContent xmlns:mc="http://schemas.openxmlformats.org/markup-compatibility/2006">
-    <mc:Choice xmlns:p15="http://schemas.microsoft.com/office/powerpoint/2012/main" Requires="p15">
+  <mc:AlternateContent xmlns:mc="http://schemas.openxmlformats.org/markup-compatibility/2006" xmlns:p15="http://schemas.microsoft.com/office/powerpoint/2012/main">
+    <mc:Choice Requires="p15">
       <p:transition xmlns:p14="http://schemas.microsoft.com/office/powerpoint/2010/main" spd="slow" p14:dur="1250">
         <p15:prstTrans prst="peelOff"/>
       </p:transition>
     </mc:Choice>
-    <mc:Fallback>
+    <mc:Fallback xmlns="">
       <p:transition spd="slow">
         <p:fade/>
       </p:transition>
@@ -28253,13 +28253,13 @@
   <p:clrMapOvr>
     <a:masterClrMapping/>
   </p:clrMapOvr>
-  <mc:AlternateContent xmlns:mc="http://schemas.openxmlformats.org/markup-compatibility/2006">
-    <mc:Choice xmlns:p15="http://schemas.microsoft.com/office/powerpoint/2012/main" Requires="p15">
+  <mc:AlternateContent xmlns:mc="http://schemas.openxmlformats.org/markup-compatibility/2006" xmlns:p15="http://schemas.microsoft.com/office/powerpoint/2012/main">
+    <mc:Choice Requires="p15">
       <p:transition xmlns:p14="http://schemas.microsoft.com/office/powerpoint/2010/main" spd="slow" p14:dur="1250">
         <p15:prstTrans prst="peelOff"/>
       </p:transition>
     </mc:Choice>
-    <mc:Fallback>
+    <mc:Fallback xmlns="">
       <p:transition spd="slow">
         <p:fade/>
       </p:transition>
@@ -28928,13 +28928,13 @@
   <p:clrMapOvr>
     <a:masterClrMapping/>
   </p:clrMapOvr>
-  <mc:AlternateContent xmlns:mc="http://schemas.openxmlformats.org/markup-compatibility/2006">
-    <mc:Choice xmlns:p15="http://schemas.microsoft.com/office/powerpoint/2012/main" Requires="p15">
+  <mc:AlternateContent xmlns:mc="http://schemas.openxmlformats.org/markup-compatibility/2006" xmlns:p15="http://schemas.microsoft.com/office/powerpoint/2012/main">
+    <mc:Choice Requires="p15">
       <p:transition xmlns:p14="http://schemas.microsoft.com/office/powerpoint/2010/main" spd="slow" p14:dur="1250">
         <p15:prstTrans prst="peelOff"/>
       </p:transition>
     </mc:Choice>
-    <mc:Fallback>
+    <mc:Fallback xmlns="">
       <p:transition spd="slow">
         <p:fade/>
       </p:transition>
@@ -29525,13 +29525,13 @@
   <p:clrMapOvr>
     <a:masterClrMapping/>
   </p:clrMapOvr>
-  <mc:AlternateContent xmlns:mc="http://schemas.openxmlformats.org/markup-compatibility/2006">
-    <mc:Choice xmlns:p15="http://schemas.microsoft.com/office/powerpoint/2012/main" Requires="p15">
+  <mc:AlternateContent xmlns:mc="http://schemas.openxmlformats.org/markup-compatibility/2006" xmlns:p15="http://schemas.microsoft.com/office/powerpoint/2012/main">
+    <mc:Choice Requires="p15">
       <p:transition xmlns:p14="http://schemas.microsoft.com/office/powerpoint/2010/main" spd="slow" p14:dur="1250">
         <p15:prstTrans prst="peelOff"/>
       </p:transition>
     </mc:Choice>
-    <mc:Fallback>
+    <mc:Fallback xmlns="">
       <p:transition spd="slow">
         <p:fade/>
       </p:transition>
@@ -30271,13 +30271,13 @@
   <p:clrMapOvr>
     <a:masterClrMapping/>
   </p:clrMapOvr>
-  <mc:AlternateContent xmlns:mc="http://schemas.openxmlformats.org/markup-compatibility/2006">
-    <mc:Choice xmlns:p15="http://schemas.microsoft.com/office/powerpoint/2012/main" Requires="p15">
+  <mc:AlternateContent xmlns:mc="http://schemas.openxmlformats.org/markup-compatibility/2006" xmlns:p15="http://schemas.microsoft.com/office/powerpoint/2012/main">
+    <mc:Choice Requires="p15">
       <p:transition xmlns:p14="http://schemas.microsoft.com/office/powerpoint/2010/main" spd="slow" p14:dur="1250">
         <p15:prstTrans prst="peelOff"/>
       </p:transition>
     </mc:Choice>
-    <mc:Fallback>
+    <mc:Fallback xmlns="">
       <p:transition spd="slow">
         <p:fade/>
       </p:transition>
@@ -30942,13 +30942,13 @@
   <p:clrMapOvr>
     <a:masterClrMapping/>
   </p:clrMapOvr>
-  <mc:AlternateContent xmlns:mc="http://schemas.openxmlformats.org/markup-compatibility/2006">
-    <mc:Choice xmlns:p15="http://schemas.microsoft.com/office/powerpoint/2012/main" Requires="p15">
+  <mc:AlternateContent xmlns:mc="http://schemas.openxmlformats.org/markup-compatibility/2006" xmlns:p15="http://schemas.microsoft.com/office/powerpoint/2012/main">
+    <mc:Choice Requires="p15">
       <p:transition xmlns:p14="http://schemas.microsoft.com/office/powerpoint/2010/main" spd="slow" p14:dur="1250">
         <p15:prstTrans prst="peelOff"/>
       </p:transition>
     </mc:Choice>
-    <mc:Fallback>
+    <mc:Fallback xmlns="">
       <p:transition spd="slow">
         <p:fade/>
       </p:transition>
@@ -31613,13 +31613,13 @@
   <p:clrMapOvr>
     <a:masterClrMapping/>
   </p:clrMapOvr>
-  <mc:AlternateContent xmlns:mc="http://schemas.openxmlformats.org/markup-compatibility/2006">
-    <mc:Choice xmlns:p15="http://schemas.microsoft.com/office/powerpoint/2012/main" Requires="p15">
+  <mc:AlternateContent xmlns:mc="http://schemas.openxmlformats.org/markup-compatibility/2006" xmlns:p15="http://schemas.microsoft.com/office/powerpoint/2012/main">
+    <mc:Choice Requires="p15">
       <p:transition xmlns:p14="http://schemas.microsoft.com/office/powerpoint/2010/main" spd="slow" p14:dur="1250">
         <p15:prstTrans prst="peelOff"/>
       </p:transition>
     </mc:Choice>
-    <mc:Fallback>
+    <mc:Fallback xmlns="">
       <p:transition spd="slow">
         <p:fade/>
       </p:transition>

</xml_diff>